<commit_message>
lecture fix might work tuesday added html secion
</commit_message>
<xml_diff>
--- a/docs/lectures/lecture_16/16_01_lecture_powerpoint.pptx
+++ b/docs/lectures/lecture_16/16_01_lecture_powerpoint.pptx
@@ -16081,7 +16081,7 @@
 ## 
 ## $TJH_vs_DG
 ##          Df SumOfSqs      R2      F Pr(&gt;F)   
-## Model     1   32.602 0.10636 5.7128  0.003 **
+## Model     1   32.602 0.10636 5.7128  0.002 **
 ## Residual 48  273.930 0.89364                 
 ## Total    49  306.532 1.00000                 
 ## ---
@@ -16089,7 +16089,7 @@
 ## 
 ## $TJH_vs_LEH
 ##          Df SumOfSqs      R2      F Pr(&gt;F)   
-## Model     1    47.72 0.10517 5.6414  0.004 **
+## Model     1    47.72 0.10517 5.6414  0.002 **
 ## Residual 48   406.06 0.89483                 
 ## Total    49   453.78 1.00000                 
 ## ---
@@ -16105,7 +16105,7 @@
 ## 
 ## $DG_vs_LEH
 ##          Df SumOfSqs      R2      F Pr(&gt;F)  
-## Model     1    26.24 0.06493 3.3333  0.018 *
+## Model     1    26.24 0.06493 3.3333  0.014 *
 ## Residual 48   377.85 0.93507                
 ## Total    49   404.09 1.00000                
 ## ---
@@ -16147,8 +16147,8 @@
 ## 
 ##     DG    HD    LEH  
 ## HD  0.006 -     -    
-## LEH 0.102 0.006 -    
-## TJH 0.006 0.006 0.012
+## LEH 0.114 0.006 -    
+## TJH 0.012 0.006 0.012
 ## 
 ## P value adjustment method: bonferroni</a:t>
             </a:r>

</xml_diff>